<commit_message>
Correct showcase financial labels and sharpen evidence boundaries
Refresh real Nexus captures and synthetic inputs. Make the founder's product judgment explicit and describe orchestration without publishing private source contracts or verification results.

Co-Authored-By: GPT-6 <noreply@openai.com>
Agent-Role: builder
Agent-Run: main
</commit_message>
<xml_diff>
--- a/assets/demo/northstar-strategy-showcase.pptx
+++ b/assets/demo/northstar-strategy-showcase.pptx
@@ -2,15 +2,15 @@
 <file path=ppt/presentation.xml><?xml version="1.0" encoding="utf-8"?>
 <p:presentation xmlns:p="http://schemas.openxmlformats.org/presentationml/2006/main">
   <p:sldMasterIdLst>
-    <p:sldMasterId xmlns:r="http://schemas.openxmlformats.org/officeDocument/2006/relationships" id="2147483648" r:id="R31556e972d4c4a5b"/>
+    <p:sldMasterId xmlns:r="http://schemas.openxmlformats.org/officeDocument/2006/relationships" id="2147483648" r:id="R86e0c290e5804af4"/>
   </p:sldMasterIdLst>
   <p:notesMasterIdLst>
-    <p:notesMasterId xmlns:r="http://schemas.openxmlformats.org/officeDocument/2006/relationships" r:id="Rdc8091812f0b417e"/>
+    <p:notesMasterId xmlns:r="http://schemas.openxmlformats.org/officeDocument/2006/relationships" r:id="R995b55fb2da9444e"/>
   </p:notesMasterIdLst>
   <p:sldIdLst>
-    <p:sldId xmlns:r="http://schemas.openxmlformats.org/officeDocument/2006/relationships" id="256" r:id="Rf2e7cc2eacc44173"/>
-    <p:sldId xmlns:r="http://schemas.openxmlformats.org/officeDocument/2006/relationships" id="257" r:id="R31a32ca67fd246ba"/>
-    <p:sldId xmlns:r="http://schemas.openxmlformats.org/officeDocument/2006/relationships" id="258" r:id="R753daff502c541b4"/>
+    <p:sldId xmlns:r="http://schemas.openxmlformats.org/officeDocument/2006/relationships" id="256" r:id="R560ab2e59ac14018"/>
+    <p:sldId xmlns:r="http://schemas.openxmlformats.org/officeDocument/2006/relationships" id="257" r:id="Rc57b61589e6348c9"/>
+    <p:sldId xmlns:r="http://schemas.openxmlformats.org/officeDocument/2006/relationships" id="258" r:id="R5f0c4f5bed8e4358"/>
   </p:sldIdLst>
   <p:sldSz cx="12192000" cy="6858000"/>
   <p:notesSz cx="6858000" cy="9144000"/>
@@ -444,7 +444,7 @@
           <a:lstStyle xmlns:a="http://schemas.openxmlformats.org/drawingml/2006/main"/>
           <a:p xmlns:a="http://schemas.openxmlformats.org/drawingml/2006/main">
             <a:r>
-              <a:t>All company names, inputs, economics and recommendations in this deck are fictional and synthetic. No employer information. Assumptions: 20 sites, 100 monthly visits per site, $500 revenue per visit. Base direct cost 62%, downside 70%. Fixed monthly cost $260,000. Monthly revenue $1,000,000. Base contribution $120,000, downside $40,000. Illustrative analysis, not a real engagement or demonstrated business impact.</a:t>
+              <a:t>All company names, inputs, economics and recommendations in this deck are fictional and synthetic. No employer information. Assumptions: 20 sites, 100 monthly visits per site, $500 revenue per visit. Base direct cost 62%, downside 70%. Fixed monthly cost $260,000. Monthly revenue $1,000,000. Base operating surplus $120,000, downside $40,000. Illustrative analysis, not a real engagement or demonstrated business impact.</a:t>
             </a:r>
           </a:p>
         </p:txBody>
@@ -514,7 +514,7 @@
           <a:lstStyle xmlns:a="http://schemas.openxmlformats.org/drawingml/2006/main"/>
           <a:p xmlns:a="http://schemas.openxmlformats.org/drawingml/2006/main">
             <a:r>
-              <a:t>All company names, inputs, economics and recommendations in this deck are fictional and synthetic. No employer information. Assumptions: 20 sites, 100 monthly visits per site, $500 revenue per visit. Base direct cost 62%, downside 70%. Fixed monthly cost $260,000. Monthly revenue $1,000,000. Base contribution $120,000, downside $40,000. Illustrative analysis, not a real engagement or demonstrated business impact.</a:t>
+              <a:t>All company names, inputs, economics and recommendations in this deck are fictional and synthetic. No employer information. Assumptions: 20 sites, 100 monthly visits per site, $500 revenue per visit. Base direct cost 62%, downside 70%. Fixed monthly cost $260,000. Monthly revenue $1,000,000. Base operating surplus $120,000, downside $40,000. Illustrative analysis, not a real engagement or demonstrated business impact.</a:t>
             </a:r>
           </a:p>
         </p:txBody>
@@ -584,7 +584,7 @@
           <a:lstStyle xmlns:a="http://schemas.openxmlformats.org/drawingml/2006/main"/>
           <a:p xmlns:a="http://schemas.openxmlformats.org/drawingml/2006/main">
             <a:r>
-              <a:t>All company names, inputs, economics and recommendations in this deck are fictional and synthetic. No employer information. Assumptions: 20 sites, 100 monthly visits per site, $500 revenue per visit. Base direct cost 62%, downside 70%. Fixed monthly cost $260,000. Monthly revenue $1,000,000. Base contribution $120,000, downside $40,000. Illustrative analysis, not a real engagement or demonstrated business impact.</a:t>
+              <a:t>All company names, inputs, economics and recommendations in this deck are fictional and synthetic. No employer information. Assumptions: 20 sites, 100 monthly visits per site, $500 revenue per visit. Base direct cost 62%, downside 70%. Fixed monthly cost $260,000. Monthly revenue $1,000,000. Base operating surplus $120,000, downside $40,000. Illustrative analysis, not a real engagement or demonstrated business impact.</a:t>
             </a:r>
           </a:p>
         </p:txBody>
@@ -652,7 +652,7 @@
   </p:cSld>
   <p:clrMap bg1="lt1" tx1="dk1" bg2="lt2" tx2="dk2" accent1="accent1" accent2="accent2" accent3="accent3" accent4="accent4" accent5="accent5" accent6="accent6" hlink="hlink" folHlink="folHlink"/>
   <p:sldLayoutIdLst>
-    <p:sldLayoutId xmlns:r="http://schemas.openxmlformats.org/officeDocument/2006/relationships" id="2147483649" r:id="R2eee434ccbe24fb2"/>
+    <p:sldLayoutId xmlns:r="http://schemas.openxmlformats.org/officeDocument/2006/relationships" id="2147483649" r:id="Rbc734946f3f54911"/>
   </p:sldLayoutIdLst>
   <p:txStyles>
     <p:titleStyle>
@@ -1192,7 +1192,7 @@
           <c:idx val="0"/>
           <c:order val="0"/>
           <c:tx>
-            <c:v>Contribution ($000)</c:v>
+            <c:v>Operating surplus ($000)</c:v>
           </c:tx>
           <c:spPr>
             <a:solidFill xmlns:a="http://schemas.openxmlformats.org/drawingml/2006/main">
@@ -1371,7 +1371,7 @@
           <p:cNvPr id="12" name="">
             <a:extLst xmlns:a="http://schemas.openxmlformats.org/drawingml/2006/main">
               <a:ext uri="{FF2B5EF4-FFF2-40B4-BE49-F238E27FC236}">
-                <a16:creationId xmlns:a16="http://schemas.microsoft.com/office/drawing/2014/main" id="{44148A9D-E91D-40FA-8B3C-5A4DFDADB343}"/>
+                <a16:creationId xmlns:a16="http://schemas.microsoft.com/office/drawing/2014/main" id="{C7B384C1-0358-4CA7-8E2F-522BCE5D99C4}"/>
               </a:ext>
             </a:extLst>
           </p:cNvPr>
@@ -1428,7 +1428,7 @@
           <p:cNvPr id="2" name="">
             <a:extLst xmlns:a="http://schemas.openxmlformats.org/drawingml/2006/main">
               <a:ext uri="{FF2B5EF4-FFF2-40B4-BE49-F238E27FC236}">
-                <a16:creationId xmlns:a16="http://schemas.microsoft.com/office/drawing/2014/main" id="{2522A562-D9C2-40CC-87C5-05DEDF956254}"/>
+                <a16:creationId xmlns:a16="http://schemas.microsoft.com/office/drawing/2014/main" id="{720FC31D-1787-469F-B8C3-BA339E83FC81}"/>
               </a:ext>
             </a:extLst>
           </p:cNvPr>
@@ -1485,7 +1485,7 @@
           <p:cNvPr id="3" name="">
             <a:extLst xmlns:a="http://schemas.openxmlformats.org/drawingml/2006/main">
               <a:ext uri="{FF2B5EF4-FFF2-40B4-BE49-F238E27FC236}">
-                <a16:creationId xmlns:a16="http://schemas.microsoft.com/office/drawing/2014/main" id="{31B81781-3057-4D23-B3C7-FA839F349F36}"/>
+                <a16:creationId xmlns:a16="http://schemas.microsoft.com/office/drawing/2014/main" id="{CC3F2E4A-A1A3-4987-8488-99932E76B188}"/>
               </a:ext>
             </a:extLst>
           </p:cNvPr>
@@ -1542,7 +1542,7 @@
           <p:cNvPr id="4" name="">
             <a:extLst xmlns:a="http://schemas.openxmlformats.org/drawingml/2006/main">
               <a:ext uri="{FF2B5EF4-FFF2-40B4-BE49-F238E27FC236}">
-                <a16:creationId xmlns:a16="http://schemas.microsoft.com/office/drawing/2014/main" id="{3FDB736E-F568-4F17-80D5-7067FDF0871B}"/>
+                <a16:creationId xmlns:a16="http://schemas.microsoft.com/office/drawing/2014/main" id="{26D02195-1938-4277-BBB8-36F5FAF6A2E8}"/>
               </a:ext>
             </a:extLst>
           </p:cNvPr>
@@ -1599,7 +1599,7 @@
           <p:cNvPr id="5" name="">
             <a:extLst xmlns:a="http://schemas.openxmlformats.org/drawingml/2006/main">
               <a:ext uri="{FF2B5EF4-FFF2-40B4-BE49-F238E27FC236}">
-                <a16:creationId xmlns:a16="http://schemas.microsoft.com/office/drawing/2014/main" id="{3F2DF516-C1B0-4A83-8FA8-14B790C2E264}"/>
+                <a16:creationId xmlns:a16="http://schemas.microsoft.com/office/drawing/2014/main" id="{10FA4ADC-96B2-4CAB-AB54-BB6CC7135958}"/>
               </a:ext>
             </a:extLst>
           </p:cNvPr>
@@ -1646,7 +1646,7 @@
                 <a:ea typeface="Arial"/>
                 <a:cs typeface="Arial"/>
               </a:rPr>
-              <a:t>Monthly contribution at 20 sites</a:t>
+              <a:t>Operating surplus at 20 sites</a:t>
             </a:r>
           </a:p>
         </p:txBody>
@@ -1663,7 +1663,7 @@
         </p:xfrm>
         <a:graphic xmlns:a="http://schemas.openxmlformats.org/drawingml/2006/main">
           <a:graphicData uri="http://schemas.openxmlformats.org/drawingml/2006/chart">
-            <c:chart xmlns:r="http://schemas.openxmlformats.org/officeDocument/2006/relationships" xmlns:c="http://schemas.openxmlformats.org/drawingml/2006/chart" r:id="R7805ba85571e49d0"/>
+            <c:chart xmlns:r="http://schemas.openxmlformats.org/officeDocument/2006/relationships" xmlns:c="http://schemas.openxmlformats.org/drawingml/2006/chart" r:id="Rf76cbacb14fa4ba5"/>
           </a:graphicData>
         </a:graphic>
       </p:graphicFrame>
@@ -1672,7 +1672,7 @@
           <p:cNvPr id="7" name="">
             <a:extLst xmlns:a="http://schemas.openxmlformats.org/drawingml/2006/main">
               <a:ext uri="{FF2B5EF4-FFF2-40B4-BE49-F238E27FC236}">
-                <a16:creationId xmlns:a16="http://schemas.microsoft.com/office/drawing/2014/main" id="{AB107559-9C39-4156-AE2A-49A2C004BE62}"/>
+                <a16:creationId xmlns:a16="http://schemas.microsoft.com/office/drawing/2014/main" id="{E18D4B09-A532-4DCD-A6D0-4107782FF423}"/>
               </a:ext>
             </a:extLst>
           </p:cNvPr>
@@ -1729,7 +1729,7 @@
           <p:cNvPr id="8" name="">
             <a:extLst xmlns:a="http://schemas.openxmlformats.org/drawingml/2006/main">
               <a:ext uri="{FF2B5EF4-FFF2-40B4-BE49-F238E27FC236}">
-                <a16:creationId xmlns:a16="http://schemas.microsoft.com/office/drawing/2014/main" id="{6B69E4F2-D086-40B2-B8FC-DAC25D51E66B}"/>
+                <a16:creationId xmlns:a16="http://schemas.microsoft.com/office/drawing/2014/main" id="{859F021A-191C-4593-AF48-E065ACDF8D0B}"/>
               </a:ext>
             </a:extLst>
           </p:cNvPr>
@@ -1809,7 +1809,7 @@
           <p:cNvPr id="9" name="">
             <a:extLst xmlns:a="http://schemas.openxmlformats.org/drawingml/2006/main">
               <a:ext uri="{FF2B5EF4-FFF2-40B4-BE49-F238E27FC236}">
-                <a16:creationId xmlns:a16="http://schemas.microsoft.com/office/drawing/2014/main" id="{68E85D72-C47E-4495-A227-2B3551E663AC}"/>
+                <a16:creationId xmlns:a16="http://schemas.microsoft.com/office/drawing/2014/main" id="{F5E47D18-2140-4711-9A4A-DD88E03F1F69}"/>
               </a:ext>
             </a:extLst>
           </p:cNvPr>
@@ -1866,7 +1866,7 @@
           <p:cNvPr id="10" name="">
             <a:extLst xmlns:a="http://schemas.openxmlformats.org/drawingml/2006/main">
               <a:ext uri="{FF2B5EF4-FFF2-40B4-BE49-F238E27FC236}">
-                <a16:creationId xmlns:a16="http://schemas.microsoft.com/office/drawing/2014/main" id="{D35EB58C-61A7-4225-918B-A9AFFE007FDB}"/>
+                <a16:creationId xmlns:a16="http://schemas.microsoft.com/office/drawing/2014/main" id="{994E6E2B-7F66-4E84-A879-D1C6BC9D160E}"/>
               </a:ext>
             </a:extLst>
           </p:cNvPr>
@@ -1969,7 +1969,7 @@
           <p:cNvPr id="11" name="">
             <a:extLst xmlns:a="http://schemas.openxmlformats.org/drawingml/2006/main">
               <a:ext uri="{FF2B5EF4-FFF2-40B4-BE49-F238E27FC236}">
-                <a16:creationId xmlns:a16="http://schemas.microsoft.com/office/drawing/2014/main" id="{92B2339B-9D81-4F15-9F10-4B5AABB44DE6}"/>
+                <a16:creationId xmlns:a16="http://schemas.microsoft.com/office/drawing/2014/main" id="{DB9CC215-7104-4A30-84D8-048B90B9DDDD}"/>
               </a:ext>
             </a:extLst>
           </p:cNvPr>
@@ -2024,7 +2024,7 @@
     </p:spTree>
     <p:extLst>
       <p:ext uri="{BB962C8B-B14F-4D97-AF65-F5344CB8AC3E}">
-        <p14:creationId xmlns:p14="http://schemas.microsoft.com/office/powerpoint/2010/main" val="967088872"/>
+        <p14:creationId xmlns:p14="http://schemas.microsoft.com/office/powerpoint/2010/main" val="462150582"/>
       </p:ext>
     </p:extLst>
   </p:cSld>
@@ -2055,7 +2055,7 @@
           <p:cNvPr id="17" name="">
             <a:extLst xmlns:a="http://schemas.openxmlformats.org/drawingml/2006/main">
               <a:ext uri="{FF2B5EF4-FFF2-40B4-BE49-F238E27FC236}">
-                <a16:creationId xmlns:a16="http://schemas.microsoft.com/office/drawing/2014/main" id="{7CEFEC4E-8801-4C73-8491-5FD9FA0F09BB}"/>
+                <a16:creationId xmlns:a16="http://schemas.microsoft.com/office/drawing/2014/main" id="{F278D9A6-413A-40C2-B27F-C80F229849F2}"/>
               </a:ext>
             </a:extLst>
           </p:cNvPr>
@@ -2112,7 +2112,7 @@
           <p:cNvPr id="2" name="">
             <a:extLst xmlns:a="http://schemas.openxmlformats.org/drawingml/2006/main">
               <a:ext uri="{FF2B5EF4-FFF2-40B4-BE49-F238E27FC236}">
-                <a16:creationId xmlns:a16="http://schemas.microsoft.com/office/drawing/2014/main" id="{441FBB32-05A3-43CA-8BBF-124AF45A97D1}"/>
+                <a16:creationId xmlns:a16="http://schemas.microsoft.com/office/drawing/2014/main" id="{087A4A21-5330-4BDD-961C-F83DBDE31995}"/>
               </a:ext>
             </a:extLst>
           </p:cNvPr>
@@ -2169,7 +2169,7 @@
           <p:cNvPr id="3" name="">
             <a:extLst xmlns:a="http://schemas.openxmlformats.org/drawingml/2006/main">
               <a:ext uri="{FF2B5EF4-FFF2-40B4-BE49-F238E27FC236}">
-                <a16:creationId xmlns:a16="http://schemas.microsoft.com/office/drawing/2014/main" id="{491D6677-AD8C-4EEB-8F13-A9F64747982E}"/>
+                <a16:creationId xmlns:a16="http://schemas.microsoft.com/office/drawing/2014/main" id="{CFC8185B-4F6B-41FB-9353-E00B177CD050}"/>
               </a:ext>
             </a:extLst>
           </p:cNvPr>
@@ -2226,7 +2226,7 @@
           <p:cNvPr id="4" name="">
             <a:extLst xmlns:a="http://schemas.openxmlformats.org/drawingml/2006/main">
               <a:ext uri="{FF2B5EF4-FFF2-40B4-BE49-F238E27FC236}">
-                <a16:creationId xmlns:a16="http://schemas.microsoft.com/office/drawing/2014/main" id="{F4A0B6ED-5262-40FC-9E66-6140EF1C00CB}"/>
+                <a16:creationId xmlns:a16="http://schemas.microsoft.com/office/drawing/2014/main" id="{09E4407E-F52C-4F0A-89FE-35E188F17DAF}"/>
               </a:ext>
             </a:extLst>
           </p:cNvPr>
@@ -2283,7 +2283,7 @@
           <p:cNvPr id="5" name="">
             <a:extLst xmlns:a="http://schemas.openxmlformats.org/drawingml/2006/main">
               <a:ext uri="{FF2B5EF4-FFF2-40B4-BE49-F238E27FC236}">
-                <a16:creationId xmlns:a16="http://schemas.microsoft.com/office/drawing/2014/main" id="{43ED3B13-E5A1-4EE4-AB2C-A973EC48D180}"/>
+                <a16:creationId xmlns:a16="http://schemas.microsoft.com/office/drawing/2014/main" id="{A79C6A65-4A03-4E14-8802-F545075BCD58}"/>
               </a:ext>
             </a:extLst>
           </p:cNvPr>
@@ -2340,7 +2340,7 @@
           <p:cNvPr id="6" name="">
             <a:extLst xmlns:a="http://schemas.openxmlformats.org/drawingml/2006/main">
               <a:ext uri="{FF2B5EF4-FFF2-40B4-BE49-F238E27FC236}">
-                <a16:creationId xmlns:a16="http://schemas.microsoft.com/office/drawing/2014/main" id="{62B4C874-5C96-4CFB-8EE8-DB00B05FA568}"/>
+                <a16:creationId xmlns:a16="http://schemas.microsoft.com/office/drawing/2014/main" id="{CE1B536D-EA5A-45F2-91F8-FE34325D8891}"/>
               </a:ext>
             </a:extLst>
           </p:cNvPr>
@@ -2397,7 +2397,7 @@
           <p:cNvPr id="7" name="">
             <a:extLst xmlns:a="http://schemas.openxmlformats.org/drawingml/2006/main">
               <a:ext uri="{FF2B5EF4-FFF2-40B4-BE49-F238E27FC236}">
-                <a16:creationId xmlns:a16="http://schemas.microsoft.com/office/drawing/2014/main" id="{AE269B0C-39E0-4675-8EA1-108E9B8E0DA3}"/>
+                <a16:creationId xmlns:a16="http://schemas.microsoft.com/office/drawing/2014/main" id="{6277703C-F7CD-4EA7-B608-19BBF1C2AA61}"/>
               </a:ext>
             </a:extLst>
           </p:cNvPr>
@@ -2454,7 +2454,7 @@
           <p:cNvPr id="8" name="">
             <a:extLst xmlns:a="http://schemas.openxmlformats.org/drawingml/2006/main">
               <a:ext uri="{FF2B5EF4-FFF2-40B4-BE49-F238E27FC236}">
-                <a16:creationId xmlns:a16="http://schemas.microsoft.com/office/drawing/2014/main" id="{B601A08B-21B2-4B1F-8F06-6AD1B4569021}"/>
+                <a16:creationId xmlns:a16="http://schemas.microsoft.com/office/drawing/2014/main" id="{6883705B-5518-4C9E-837E-294B32B070A2}"/>
               </a:ext>
             </a:extLst>
           </p:cNvPr>
@@ -2511,7 +2511,7 @@
           <p:cNvPr id="9" name="">
             <a:extLst xmlns:a="http://schemas.openxmlformats.org/drawingml/2006/main">
               <a:ext uri="{FF2B5EF4-FFF2-40B4-BE49-F238E27FC236}">
-                <a16:creationId xmlns:a16="http://schemas.microsoft.com/office/drawing/2014/main" id="{3EFEAF3A-9521-4E11-8846-099E32D35E98}"/>
+                <a16:creationId xmlns:a16="http://schemas.microsoft.com/office/drawing/2014/main" id="{B476C90A-4C3D-4593-BD29-1C11A5162523}"/>
               </a:ext>
             </a:extLst>
           </p:cNvPr>
@@ -2568,7 +2568,7 @@
           <p:cNvPr id="10" name="">
             <a:extLst xmlns:a="http://schemas.openxmlformats.org/drawingml/2006/main">
               <a:ext uri="{FF2B5EF4-FFF2-40B4-BE49-F238E27FC236}">
-                <a16:creationId xmlns:a16="http://schemas.microsoft.com/office/drawing/2014/main" id="{FD829DEF-33CE-46AD-87DA-8E54C2DEC6EF}"/>
+                <a16:creationId xmlns:a16="http://schemas.microsoft.com/office/drawing/2014/main" id="{AA6BD494-DCF8-47A3-B52F-35922284B840}"/>
               </a:ext>
             </a:extLst>
           </p:cNvPr>
@@ -2625,7 +2625,7 @@
           <p:cNvPr id="11" name="">
             <a:extLst xmlns:a="http://schemas.openxmlformats.org/drawingml/2006/main">
               <a:ext uri="{FF2B5EF4-FFF2-40B4-BE49-F238E27FC236}">
-                <a16:creationId xmlns:a16="http://schemas.microsoft.com/office/drawing/2014/main" id="{77939D81-71A3-4FD8-ACD5-45BD80E04521}"/>
+                <a16:creationId xmlns:a16="http://schemas.microsoft.com/office/drawing/2014/main" id="{C6718860-785E-4099-9EAC-F88718EDFA85}"/>
               </a:ext>
             </a:extLst>
           </p:cNvPr>
@@ -2682,7 +2682,7 @@
           <p:cNvPr id="12" name="">
             <a:extLst xmlns:a="http://schemas.openxmlformats.org/drawingml/2006/main">
               <a:ext uri="{FF2B5EF4-FFF2-40B4-BE49-F238E27FC236}">
-                <a16:creationId xmlns:a16="http://schemas.microsoft.com/office/drawing/2014/main" id="{1A7C9352-6EBF-46AA-8F03-A01C4019DAC2}"/>
+                <a16:creationId xmlns:a16="http://schemas.microsoft.com/office/drawing/2014/main" id="{EED8352C-55FB-4835-9D5A-96A645311668}"/>
               </a:ext>
             </a:extLst>
           </p:cNvPr>
@@ -2775,7 +2775,7 @@
                 <a:ea typeface="Arial"/>
                 <a:cs typeface="Arial"/>
               </a:rPr>
-              <a:t>$120k contribution</a:t>
+              <a:t>$120k operating surplus</a:t>
             </a:r>
           </a:p>
         </p:txBody>
@@ -2785,7 +2785,7 @@
           <p:cNvPr id="13" name="">
             <a:extLst xmlns:a="http://schemas.openxmlformats.org/drawingml/2006/main">
               <a:ext uri="{FF2B5EF4-FFF2-40B4-BE49-F238E27FC236}">
-                <a16:creationId xmlns:a16="http://schemas.microsoft.com/office/drawing/2014/main" id="{0D076986-B375-4DDF-9219-E694AA032E8E}"/>
+                <a16:creationId xmlns:a16="http://schemas.microsoft.com/office/drawing/2014/main" id="{BE95D196-1532-4BE5-8F2C-5E1544514DD7}"/>
               </a:ext>
             </a:extLst>
           </p:cNvPr>
@@ -2842,7 +2842,7 @@
           <p:cNvPr id="14" name="">
             <a:extLst xmlns:a="http://schemas.openxmlformats.org/drawingml/2006/main">
               <a:ext uri="{FF2B5EF4-FFF2-40B4-BE49-F238E27FC236}">
-                <a16:creationId xmlns:a16="http://schemas.microsoft.com/office/drawing/2014/main" id="{1E813074-2F1D-42D7-ABDE-91EBDE9E2E5B}"/>
+                <a16:creationId xmlns:a16="http://schemas.microsoft.com/office/drawing/2014/main" id="{460C6688-E2B8-45A1-A92D-BD1C7BB2783A}"/>
               </a:ext>
             </a:extLst>
           </p:cNvPr>
@@ -2935,7 +2935,7 @@
                 <a:ea typeface="Arial"/>
                 <a:cs typeface="Arial"/>
               </a:rPr>
-              <a:t>$40k contribution</a:t>
+              <a:t>$40k operating surplus</a:t>
             </a:r>
           </a:p>
         </p:txBody>
@@ -2945,7 +2945,7 @@
           <p:cNvPr id="15" name="">
             <a:extLst xmlns:a="http://schemas.openxmlformats.org/drawingml/2006/main">
               <a:ext uri="{FF2B5EF4-FFF2-40B4-BE49-F238E27FC236}">
-                <a16:creationId xmlns:a16="http://schemas.microsoft.com/office/drawing/2014/main" id="{0D8C4E34-1E2E-4BAB-B615-1173DBA6AD59}"/>
+                <a16:creationId xmlns:a16="http://schemas.microsoft.com/office/drawing/2014/main" id="{66E03E31-1E42-4D03-B964-4752F3D0ADF8}"/>
               </a:ext>
             </a:extLst>
           </p:cNvPr>
@@ -3002,7 +3002,7 @@
           <p:cNvPr id="16" name="">
             <a:extLst xmlns:a="http://schemas.openxmlformats.org/drawingml/2006/main">
               <a:ext uri="{FF2B5EF4-FFF2-40B4-BE49-F238E27FC236}">
-                <a16:creationId xmlns:a16="http://schemas.microsoft.com/office/drawing/2014/main" id="{048FDDE9-8DE4-4916-AA2A-A2D5D275E6EC}"/>
+                <a16:creationId xmlns:a16="http://schemas.microsoft.com/office/drawing/2014/main" id="{99B5E574-5782-4DD0-A362-771381D7171B}"/>
               </a:ext>
             </a:extLst>
           </p:cNvPr>
@@ -3103,7 +3103,7 @@
     </p:spTree>
     <p:extLst>
       <p:ext uri="{BB962C8B-B14F-4D97-AF65-F5344CB8AC3E}">
-        <p14:creationId xmlns:p14="http://schemas.microsoft.com/office/powerpoint/2010/main" val="103180440"/>
+        <p14:creationId xmlns:p14="http://schemas.microsoft.com/office/powerpoint/2010/main" val="857503865"/>
       </p:ext>
     </p:extLst>
   </p:cSld>
@@ -3134,7 +3134,7 @@
           <p:cNvPr id="13" name="">
             <a:extLst xmlns:a="http://schemas.openxmlformats.org/drawingml/2006/main">
               <a:ext uri="{FF2B5EF4-FFF2-40B4-BE49-F238E27FC236}">
-                <a16:creationId xmlns:a16="http://schemas.microsoft.com/office/drawing/2014/main" id="{5F4D77A2-90EB-4F9C-8FD6-D1CA754BE25C}"/>
+                <a16:creationId xmlns:a16="http://schemas.microsoft.com/office/drawing/2014/main" id="{FACA1A5C-9C1C-42F6-8974-9A3316598B37}"/>
               </a:ext>
             </a:extLst>
           </p:cNvPr>
@@ -3191,7 +3191,7 @@
           <p:cNvPr id="2" name="">
             <a:extLst xmlns:a="http://schemas.openxmlformats.org/drawingml/2006/main">
               <a:ext uri="{FF2B5EF4-FFF2-40B4-BE49-F238E27FC236}">
-                <a16:creationId xmlns:a16="http://schemas.microsoft.com/office/drawing/2014/main" id="{5F050ABF-F7A2-4C20-9324-C0B82360CF47}"/>
+                <a16:creationId xmlns:a16="http://schemas.microsoft.com/office/drawing/2014/main" id="{087F3983-EBA3-4C31-871A-F957FEE5B6DB}"/>
               </a:ext>
             </a:extLst>
           </p:cNvPr>
@@ -3248,7 +3248,7 @@
           <p:cNvPr id="3" name="">
             <a:extLst xmlns:a="http://schemas.openxmlformats.org/drawingml/2006/main">
               <a:ext uri="{FF2B5EF4-FFF2-40B4-BE49-F238E27FC236}">
-                <a16:creationId xmlns:a16="http://schemas.microsoft.com/office/drawing/2014/main" id="{944DA476-7823-4A2E-9C84-D1DEE43AFA1C}"/>
+                <a16:creationId xmlns:a16="http://schemas.microsoft.com/office/drawing/2014/main" id="{DA6D8006-163D-4BB5-B2BD-4B3D0B361521}"/>
               </a:ext>
             </a:extLst>
           </p:cNvPr>
@@ -3305,7 +3305,7 @@
           <p:cNvPr id="4" name="">
             <a:extLst xmlns:a="http://schemas.openxmlformats.org/drawingml/2006/main">
               <a:ext uri="{FF2B5EF4-FFF2-40B4-BE49-F238E27FC236}">
-                <a16:creationId xmlns:a16="http://schemas.microsoft.com/office/drawing/2014/main" id="{EB706911-4463-4190-8D3A-EE4F06E7422D}"/>
+                <a16:creationId xmlns:a16="http://schemas.microsoft.com/office/drawing/2014/main" id="{AA77F691-6275-44F2-99CD-E1C38C8AECD2}"/>
               </a:ext>
             </a:extLst>
           </p:cNvPr>
@@ -3362,7 +3362,7 @@
           <p:cNvPr id="5" name="">
             <a:extLst xmlns:a="http://schemas.openxmlformats.org/drawingml/2006/main">
               <a:ext uri="{FF2B5EF4-FFF2-40B4-BE49-F238E27FC236}">
-                <a16:creationId xmlns:a16="http://schemas.microsoft.com/office/drawing/2014/main" id="{E30EFBA8-8B86-4956-A8A4-62450268912F}"/>
+                <a16:creationId xmlns:a16="http://schemas.microsoft.com/office/drawing/2014/main" id="{C1902665-8F2D-4FF4-8CAD-B4552F8EEE8E}"/>
               </a:ext>
             </a:extLst>
           </p:cNvPr>
@@ -3419,7 +3419,7 @@
           <p:cNvPr id="6" name="">
             <a:extLst xmlns:a="http://schemas.openxmlformats.org/drawingml/2006/main">
               <a:ext uri="{FF2B5EF4-FFF2-40B4-BE49-F238E27FC236}">
-                <a16:creationId xmlns:a16="http://schemas.microsoft.com/office/drawing/2014/main" id="{04A43E01-75C4-4FE5-8169-E152342397D8}"/>
+                <a16:creationId xmlns:a16="http://schemas.microsoft.com/office/drawing/2014/main" id="{E8AD43D0-04D7-4CA3-8507-ED89CA784D6A}"/>
               </a:ext>
             </a:extLst>
           </p:cNvPr>
@@ -3499,7 +3499,7 @@
           <p:cNvPr id="7" name="">
             <a:extLst xmlns:a="http://schemas.openxmlformats.org/drawingml/2006/main">
               <a:ext uri="{FF2B5EF4-FFF2-40B4-BE49-F238E27FC236}">
-                <a16:creationId xmlns:a16="http://schemas.microsoft.com/office/drawing/2014/main" id="{37CACF07-AA00-474A-A67A-8F224485841B}"/>
+                <a16:creationId xmlns:a16="http://schemas.microsoft.com/office/drawing/2014/main" id="{FDEB4D9B-6EDB-4017-B415-60810C8453A8}"/>
               </a:ext>
             </a:extLst>
           </p:cNvPr>
@@ -3556,7 +3556,7 @@
           <p:cNvPr id="8" name="">
             <a:extLst xmlns:a="http://schemas.openxmlformats.org/drawingml/2006/main">
               <a:ext uri="{FF2B5EF4-FFF2-40B4-BE49-F238E27FC236}">
-                <a16:creationId xmlns:a16="http://schemas.microsoft.com/office/drawing/2014/main" id="{0F7B4E7E-E02B-4675-94E9-7B1686DD8FD8}"/>
+                <a16:creationId xmlns:a16="http://schemas.microsoft.com/office/drawing/2014/main" id="{84AFBF6E-AC50-429F-A2C6-AFAEB1800119}"/>
               </a:ext>
             </a:extLst>
           </p:cNvPr>
@@ -3636,7 +3636,7 @@
           <p:cNvPr id="9" name="">
             <a:extLst xmlns:a="http://schemas.openxmlformats.org/drawingml/2006/main">
               <a:ext uri="{FF2B5EF4-FFF2-40B4-BE49-F238E27FC236}">
-                <a16:creationId xmlns:a16="http://schemas.microsoft.com/office/drawing/2014/main" id="{74C0B4EE-AEAB-45F5-8236-471F55366268}"/>
+                <a16:creationId xmlns:a16="http://schemas.microsoft.com/office/drawing/2014/main" id="{806C3EC0-B47C-430D-8416-AF659F197427}"/>
               </a:ext>
             </a:extLst>
           </p:cNvPr>
@@ -3693,7 +3693,7 @@
           <p:cNvPr id="10" name="">
             <a:extLst xmlns:a="http://schemas.openxmlformats.org/drawingml/2006/main">
               <a:ext uri="{FF2B5EF4-FFF2-40B4-BE49-F238E27FC236}">
-                <a16:creationId xmlns:a16="http://schemas.microsoft.com/office/drawing/2014/main" id="{F14D2BAF-5F88-486D-B7BE-9CB1766E0A9C}"/>
+                <a16:creationId xmlns:a16="http://schemas.microsoft.com/office/drawing/2014/main" id="{82031127-9ADE-4873-BAD5-1F729B8A5C94}"/>
               </a:ext>
             </a:extLst>
           </p:cNvPr>
@@ -3773,7 +3773,7 @@
           <p:cNvPr id="11" name="">
             <a:extLst xmlns:a="http://schemas.openxmlformats.org/drawingml/2006/main">
               <a:ext uri="{FF2B5EF4-FFF2-40B4-BE49-F238E27FC236}">
-                <a16:creationId xmlns:a16="http://schemas.microsoft.com/office/drawing/2014/main" id="{F13E6C31-129D-4576-AE16-BB1818C6EDF4}"/>
+                <a16:creationId xmlns:a16="http://schemas.microsoft.com/office/drawing/2014/main" id="{4D855996-D397-4A5C-AD62-B9B4874C65D5}"/>
               </a:ext>
             </a:extLst>
           </p:cNvPr>
@@ -3830,7 +3830,7 @@
           <p:cNvPr id="12" name="">
             <a:extLst xmlns:a="http://schemas.openxmlformats.org/drawingml/2006/main">
               <a:ext uri="{FF2B5EF4-FFF2-40B4-BE49-F238E27FC236}">
-                <a16:creationId xmlns:a16="http://schemas.microsoft.com/office/drawing/2014/main" id="{3589B9E3-D036-45C7-BE8E-B4E7BA4320C4}"/>
+                <a16:creationId xmlns:a16="http://schemas.microsoft.com/office/drawing/2014/main" id="{73E37CFE-C0CB-494D-947D-69428B7F5823}"/>
               </a:ext>
             </a:extLst>
           </p:cNvPr>
@@ -3908,7 +3908,7 @@
     </p:spTree>
     <p:extLst>
       <p:ext uri="{BB962C8B-B14F-4D97-AF65-F5344CB8AC3E}">
-        <p14:creationId xmlns:p14="http://schemas.microsoft.com/office/powerpoint/2010/main" val="1433291733"/>
+        <p14:creationId xmlns:p14="http://schemas.microsoft.com/office/powerpoint/2010/main" val="88908379"/>
       </p:ext>
     </p:extLst>
   </p:cSld>

</xml_diff>